<commit_message>
Ampliar la presentación a 15 diapositivas
Objetivo y fuentes, detalle de cada factor (dato del CEDI, criterio de la
tabla y coeficiente), escenarios, recomendaciones, conclusión y referencias.

Co-Authored-By: Claude Opus 5.5 <noreply@anthropic.com>
Claude-Session: https://claude.ai/code/session_01EYd8j6jaTfGGnYZUrfHhtJ
</commit_message>
<xml_diff>
--- a/Angely_Osorio_SO_C2_E133_Exposicion_celular.pptx
+++ b/Angely_Osorio_SO_C2_E133_Exposicion_celular.pptx
@@ -13,9 +13,16 @@
     <p:sldId id="261" r:id="rId7"/>
     <p:sldId id="262" r:id="rId8"/>
     <p:sldId id="263" r:id="rId9"/>
+    <p:sldId id="264" r:id="rId10"/>
+    <p:sldId id="265" r:id="rId11"/>
+    <p:sldId id="266" r:id="rId12"/>
+    <p:sldId id="267" r:id="rId13"/>
+    <p:sldId id="268" r:id="rId14"/>
+    <p:sldId id="269" r:id="rId15"/>
+    <p:sldId id="270" r:id="rId16"/>
   </p:sldIdLst>
   <p:notesMasterIdLst>
-    <p:notesMasterId r:id="rId10"/>
+    <p:notesMasterId r:id="rId17"/>
   </p:notesMasterIdLst>
   <p:sldSz cx="12192000" cy="6858000"/>
   <p:notesSz cx="6858000" cy="12192000"/>
@@ -551,7 +558,623 @@
 </p:notes>
 </file>
 
+<file path=ppt/notesSlides/notesSlide10.xml><?xml version="1.0" encoding="utf-8"?>
+<p:notes xmlns:a="http://schemas.openxmlformats.org/drawingml/2006/main" xmlns:r="http://schemas.openxmlformats.org/officeDocument/2006/relationships" xmlns:p="http://schemas.openxmlformats.org/presentationml/2006/main">
+  <p:cSld>
+    <p:spTree>
+      <p:nvGrpSpPr>
+        <p:cNvPr id="1" name=""/>
+        <p:cNvGrpSpPr/>
+        <p:nvPr/>
+      </p:nvGrpSpPr>
+      <p:grpSpPr>
+        <a:xfrm>
+          <a:off x="0" y="0"/>
+          <a:ext cx="0" cy="0"/>
+          <a:chOff x="0" y="0"/>
+          <a:chExt cx="0" cy="0"/>
+        </a:xfrm>
+      </p:grpSpPr>
+      <p:sp>
+        <p:nvSpPr>
+          <p:cNvPr id="2" name="Slide Image Placeholder 1"/>
+          <p:cNvSpPr>
+            <a:spLocks noGrp="1" noRot="1" noChangeAspect="1"/>
+          </p:cNvSpPr>
+          <p:nvPr>
+            <p:ph type="sldImg"/>
+          </p:nvPr>
+        </p:nvSpPr>
+        <p:spPr/>
+      </p:sp>
+      <p:sp>
+        <p:nvSpPr>
+          <p:cNvPr id="3" name="Notes Placeholder 2"/>
+          <p:cNvSpPr>
+            <a:spLocks noGrp="1"/>
+          </p:cNvSpPr>
+          <p:nvPr>
+            <p:ph type="body" idx="1"/>
+          </p:nvPr>
+        </p:nvSpPr>
+        <p:spPr/>
+        <p:txBody>
+          <a:bodyPr/>
+          <a:lstStyle/>
+          <a:p>
+            <a:r>
+              <a:rPr lang="en-US" dirty="0"/>
+              <a:t>En protección le va muy bien: 22 de 26 puntos. Tiene rociadores automáticos en todo el edificio, que es lo que más suma, con 8 puntos. Además tiene detección automática, gabinetes contra incendio, un hidrante exterior y extintores señalizados. Todo cuenta con vigilancia permanente y mantenimiento.</a:t>
+            </a:r>
+            <a:endParaRPr lang="en-US" dirty="0"/>
+          </a:p>
+        </p:txBody>
+      </p:sp>
+      <p:sp>
+        <p:nvSpPr>
+          <p:cNvPr id="4" name="Slide Number Placeholder 3"/>
+          <p:cNvSpPr>
+            <a:spLocks noGrp="1"/>
+          </p:cNvSpPr>
+          <p:nvPr>
+            <p:ph type="sldNum" sz="quarter" idx="10"/>
+          </p:nvPr>
+        </p:nvSpPr>
+        <p:spPr/>
+        <p:txBody>
+          <a:bodyPr/>
+          <a:lstStyle/>
+          <a:p>
+            <a:fld id="{F7021451-1387-4CA6-816F-3879F97B5CBC}" type="slidenum">
+              <a:rPr lang="en-US"/>
+              <a:t>10</a:t>
+            </a:fld>
+            <a:endParaRPr lang="en-US"/>
+          </a:p>
+        </p:txBody>
+      </p:sp>
+    </p:spTree>
+    <p:extLst>
+      <p:ext uri="{BB962C8B-B14F-4D97-AF65-F5344CB8AC3E}">
+        <p14:creationId xmlns:p14="http://schemas.microsoft.com/office/powerpoint/2010/main" val="1024086991"/>
+      </p:ext>
+    </p:extLst>
+  </p:cSld>
+  <p:clrMapOvr>
+    <a:masterClrMapping/>
+  </p:clrMapOvr>
+</p:notes>
+</file>
+
+<file path=ppt/notesSlides/notesSlide11.xml><?xml version="1.0" encoding="utf-8"?>
+<p:notes xmlns:a="http://schemas.openxmlformats.org/drawingml/2006/main" xmlns:r="http://schemas.openxmlformats.org/officeDocument/2006/relationships" xmlns:p="http://schemas.openxmlformats.org/presentationml/2006/main">
+  <p:cSld>
+    <p:spTree>
+      <p:nvGrpSpPr>
+        <p:cNvPr id="1" name=""/>
+        <p:cNvGrpSpPr/>
+        <p:nvPr/>
+      </p:nvGrpSpPr>
+      <p:grpSpPr>
+        <a:xfrm>
+          <a:off x="0" y="0"/>
+          <a:ext cx="0" cy="0"/>
+          <a:chOff x="0" y="0"/>
+          <a:chExt cx="0" cy="0"/>
+        </a:xfrm>
+      </p:grpSpPr>
+      <p:sp>
+        <p:nvSpPr>
+          <p:cNvPr id="2" name="Slide Image Placeholder 1"/>
+          <p:cNvSpPr>
+            <a:spLocks noGrp="1" noRot="1" noChangeAspect="1"/>
+          </p:cNvSpPr>
+          <p:nvPr>
+            <p:ph type="sldImg"/>
+          </p:nvPr>
+        </p:nvSpPr>
+        <p:spPr/>
+      </p:sp>
+      <p:sp>
+        <p:nvSpPr>
+          <p:cNvPr id="3" name="Notes Placeholder 2"/>
+          <p:cNvSpPr>
+            <a:spLocks noGrp="1"/>
+          </p:cNvSpPr>
+          <p:nvPr>
+            <p:ph type="body" idx="1"/>
+          </p:nvPr>
+        </p:nvSpPr>
+        <p:spPr/>
+        <p:txBody>
+          <a:bodyPr/>
+          <a:lstStyle/>
+          <a:p>
+            <a:r>
+              <a:rPr lang="en-US" dirty="0"/>
+              <a:t>Al aplicar la fórmula: 5 por 57 sobre 129 da 2,21. 5 por 22 sobre 26 da 4,23. Y la brigada suma 0, porque el CEDI no tiene brigada contra incendios. El resultado es P igual a 6,44, que corresponde a un riesgo bueno. P es el coeficiente de protección contra incendios: va de 0 a 10, y mientras más alto, más seguro está el lugar.</a:t>
+            </a:r>
+            <a:endParaRPr lang="en-US" dirty="0"/>
+          </a:p>
+        </p:txBody>
+      </p:sp>
+      <p:sp>
+        <p:nvSpPr>
+          <p:cNvPr id="4" name="Slide Number Placeholder 3"/>
+          <p:cNvSpPr>
+            <a:spLocks noGrp="1"/>
+          </p:cNvSpPr>
+          <p:nvPr>
+            <p:ph type="sldNum" sz="quarter" idx="10"/>
+          </p:nvPr>
+        </p:nvSpPr>
+        <p:spPr/>
+        <p:txBody>
+          <a:bodyPr/>
+          <a:lstStyle/>
+          <a:p>
+            <a:fld id="{F7021451-1387-4CA6-816F-3879F97B5CBC}" type="slidenum">
+              <a:rPr lang="en-US"/>
+              <a:t>11</a:t>
+            </a:fld>
+            <a:endParaRPr lang="en-US"/>
+          </a:p>
+        </p:txBody>
+      </p:sp>
+    </p:spTree>
+    <p:extLst>
+      <p:ext uri="{BB962C8B-B14F-4D97-AF65-F5344CB8AC3E}">
+        <p14:creationId xmlns:p14="http://schemas.microsoft.com/office/powerpoint/2010/main" val="1024086991"/>
+      </p:ext>
+    </p:extLst>
+  </p:cSld>
+  <p:clrMapOvr>
+    <a:masterClrMapping/>
+  </p:clrMapOvr>
+</p:notes>
+</file>
+
+<file path=ppt/notesSlides/notesSlide12.xml><?xml version="1.0" encoding="utf-8"?>
+<p:notes xmlns:a="http://schemas.openxmlformats.org/drawingml/2006/main" xmlns:r="http://schemas.openxmlformats.org/officeDocument/2006/relationships" xmlns:p="http://schemas.openxmlformats.org/presentationml/2006/main">
+  <p:cSld>
+    <p:spTree>
+      <p:nvGrpSpPr>
+        <p:cNvPr id="1" name=""/>
+        <p:cNvGrpSpPr/>
+        <p:nvPr/>
+      </p:nvGrpSpPr>
+      <p:grpSpPr>
+        <a:xfrm>
+          <a:off x="0" y="0"/>
+          <a:ext cx="0" cy="0"/>
+          <a:chOff x="0" y="0"/>
+          <a:chExt cx="0" cy="0"/>
+        </a:xfrm>
+      </p:grpSpPr>
+      <p:sp>
+        <p:nvSpPr>
+          <p:cNvPr id="2" name="Slide Image Placeholder 1"/>
+          <p:cNvSpPr>
+            <a:spLocks noGrp="1" noRot="1" noChangeAspect="1"/>
+          </p:cNvSpPr>
+          <p:nvPr>
+            <p:ph type="sldImg"/>
+          </p:nvPr>
+        </p:nvSpPr>
+        <p:spPr/>
+      </p:sp>
+      <p:sp>
+        <p:nvSpPr>
+          <p:cNvPr id="3" name="Notes Placeholder 2"/>
+          <p:cNvSpPr>
+            <a:spLocks noGrp="1"/>
+          </p:cNvSpPr>
+          <p:nvPr>
+            <p:ph type="body" idx="1"/>
+          </p:nvPr>
+        </p:nvSpPr>
+        <p:spPr/>
+        <p:txBody>
+          <a:bodyPr/>
+          <a:lstStyle/>
+          <a:p>
+            <a:r>
+              <a:rPr lang="en-US" dirty="0"/>
+              <a:t>Comparé tres escenarios. Hoy el CEDI tiene 6,44. Si se conforma una brigada contra incendios, sumaría un punto y llegaría a 7,44. Pero si no existiera la vigilancia permanente, cada medio de protección valdría menos: Y bajaría de 22 a 10 y P quedaría en 4,13, es decir, riesgo malo. Por eso es clave mantener la vigilancia y el mantenimiento.</a:t>
+            </a:r>
+            <a:endParaRPr lang="en-US" dirty="0"/>
+          </a:p>
+        </p:txBody>
+      </p:sp>
+      <p:sp>
+        <p:nvSpPr>
+          <p:cNvPr id="4" name="Slide Number Placeholder 3"/>
+          <p:cNvSpPr>
+            <a:spLocks noGrp="1"/>
+          </p:cNvSpPr>
+          <p:nvPr>
+            <p:ph type="sldNum" sz="quarter" idx="10"/>
+          </p:nvPr>
+        </p:nvSpPr>
+        <p:spPr/>
+        <p:txBody>
+          <a:bodyPr/>
+          <a:lstStyle/>
+          <a:p>
+            <a:fld id="{F7021451-1387-4CA6-816F-3879F97B5CBC}" type="slidenum">
+              <a:rPr lang="en-US"/>
+              <a:t>12</a:t>
+            </a:fld>
+            <a:endParaRPr lang="en-US"/>
+          </a:p>
+        </p:txBody>
+      </p:sp>
+    </p:spTree>
+    <p:extLst>
+      <p:ext uri="{BB962C8B-B14F-4D97-AF65-F5344CB8AC3E}">
+        <p14:creationId xmlns:p14="http://schemas.microsoft.com/office/powerpoint/2010/main" val="1024086991"/>
+      </p:ext>
+    </p:extLst>
+  </p:cSld>
+  <p:clrMapOvr>
+    <a:masterClrMapping/>
+  </p:clrMapOvr>
+</p:notes>
+</file>
+
+<file path=ppt/notesSlides/notesSlide13.xml><?xml version="1.0" encoding="utf-8"?>
+<p:notes xmlns:a="http://schemas.openxmlformats.org/drawingml/2006/main" xmlns:r="http://schemas.openxmlformats.org/officeDocument/2006/relationships" xmlns:p="http://schemas.openxmlformats.org/presentationml/2006/main">
+  <p:cSld>
+    <p:spTree>
+      <p:nvGrpSpPr>
+        <p:cNvPr id="1" name=""/>
+        <p:cNvGrpSpPr/>
+        <p:nvPr/>
+      </p:nvGrpSpPr>
+      <p:grpSpPr>
+        <a:xfrm>
+          <a:off x="0" y="0"/>
+          <a:ext cx="0" cy="0"/>
+          <a:chOff x="0" y="0"/>
+          <a:chExt cx="0" cy="0"/>
+        </a:xfrm>
+      </p:grpSpPr>
+      <p:sp>
+        <p:nvSpPr>
+          <p:cNvPr id="2" name="Slide Image Placeholder 1"/>
+          <p:cNvSpPr>
+            <a:spLocks noGrp="1" noRot="1" noChangeAspect="1"/>
+          </p:cNvSpPr>
+          <p:nvPr>
+            <p:ph type="sldImg"/>
+          </p:nvPr>
+        </p:nvSpPr>
+        <p:spPr/>
+      </p:sp>
+      <p:sp>
+        <p:nvSpPr>
+          <p:cNvPr id="3" name="Notes Placeholder 2"/>
+          <p:cNvSpPr>
+            <a:spLocks noGrp="1"/>
+          </p:cNvSpPr>
+          <p:nvPr>
+            <p:ph type="body" idx="1"/>
+          </p:nvPr>
+        </p:nvSpPr>
+        <p:spPr/>
+        <p:txBody>
+          <a:bodyPr/>
+          <a:lstStyle/>
+          <a:p>
+            <a:r>
+              <a:rPr lang="en-US" dirty="0"/>
+              <a:t>Recomiendo seis cosas: conformar y capacitar una brigada contra incendios, con la que el resultado subiría a 7,44; mantener las pruebas de rociadores, bombas, gabinetes e hidrante; corregir el cableado expuesto de la cocina; controlar la acumulación de estibas; capacitar al personal con simulacros; y evaluar muros cortafuego en futuras ampliaciones.</a:t>
+            </a:r>
+            <a:endParaRPr lang="en-US" dirty="0"/>
+          </a:p>
+        </p:txBody>
+      </p:sp>
+      <p:sp>
+        <p:nvSpPr>
+          <p:cNvPr id="4" name="Slide Number Placeholder 3"/>
+          <p:cNvSpPr>
+            <a:spLocks noGrp="1"/>
+          </p:cNvSpPr>
+          <p:nvPr>
+            <p:ph type="sldNum" sz="quarter" idx="10"/>
+          </p:nvPr>
+        </p:nvSpPr>
+        <p:spPr/>
+        <p:txBody>
+          <a:bodyPr/>
+          <a:lstStyle/>
+          <a:p>
+            <a:fld id="{F7021451-1387-4CA6-816F-3879F97B5CBC}" type="slidenum">
+              <a:rPr lang="en-US"/>
+              <a:t>13</a:t>
+            </a:fld>
+            <a:endParaRPr lang="en-US"/>
+          </a:p>
+        </p:txBody>
+      </p:sp>
+    </p:spTree>
+    <p:extLst>
+      <p:ext uri="{BB962C8B-B14F-4D97-AF65-F5344CB8AC3E}">
+        <p14:creationId xmlns:p14="http://schemas.microsoft.com/office/powerpoint/2010/main" val="1024086991"/>
+      </p:ext>
+    </p:extLst>
+  </p:cSld>
+  <p:clrMapOvr>
+    <a:masterClrMapping/>
+  </p:clrMapOvr>
+</p:notes>
+</file>
+
+<file path=ppt/notesSlides/notesSlide14.xml><?xml version="1.0" encoding="utf-8"?>
+<p:notes xmlns:a="http://schemas.openxmlformats.org/drawingml/2006/main" xmlns:r="http://schemas.openxmlformats.org/officeDocument/2006/relationships" xmlns:p="http://schemas.openxmlformats.org/presentationml/2006/main">
+  <p:cSld>
+    <p:spTree>
+      <p:nvGrpSpPr>
+        <p:cNvPr id="1" name=""/>
+        <p:cNvGrpSpPr/>
+        <p:nvPr/>
+      </p:nvGrpSpPr>
+      <p:grpSpPr>
+        <a:xfrm>
+          <a:off x="0" y="0"/>
+          <a:ext cx="0" cy="0"/>
+          <a:chOff x="0" y="0"/>
+          <a:chExt cx="0" cy="0"/>
+        </a:xfrm>
+      </p:grpSpPr>
+      <p:sp>
+        <p:nvSpPr>
+          <p:cNvPr id="2" name="Slide Image Placeholder 1"/>
+          <p:cNvSpPr>
+            <a:spLocks noGrp="1" noRot="1" noChangeAspect="1"/>
+          </p:cNvSpPr>
+          <p:nvPr>
+            <p:ph type="sldImg"/>
+          </p:nvPr>
+        </p:nvSpPr>
+        <p:spPr/>
+      </p:sp>
+      <p:sp>
+        <p:nvSpPr>
+          <p:cNvPr id="3" name="Notes Placeholder 2"/>
+          <p:cNvSpPr>
+            <a:spLocks noGrp="1"/>
+          </p:cNvSpPr>
+          <p:nvPr>
+            <p:ph type="body" idx="1"/>
+          </p:nvPr>
+        </p:nvSpPr>
+        <p:spPr/>
+        <p:txBody>
+          <a:bodyPr/>
+          <a:lstStyle/>
+          <a:p>
+            <a:r>
+              <a:rPr lang="en-US" dirty="0"/>
+              <a:t>En conclusión, el edificio tiene condiciones de riesgo altas, pero sus sistemas de protección las compensan, y el CEDI queda en riesgo bueno, con P igual a 6,44. Si se conforma una brigada, llegaría a 7,44. Muchas gracias. (Si preguntan por qué todo es con vigilancia: porque el CEDI tiene personal de seguridad permanente en portería y los equipos reciben mantenimiento.)</a:t>
+            </a:r>
+            <a:endParaRPr lang="en-US" dirty="0"/>
+          </a:p>
+        </p:txBody>
+      </p:sp>
+      <p:sp>
+        <p:nvSpPr>
+          <p:cNvPr id="4" name="Slide Number Placeholder 3"/>
+          <p:cNvSpPr>
+            <a:spLocks noGrp="1"/>
+          </p:cNvSpPr>
+          <p:nvPr>
+            <p:ph type="sldNum" sz="quarter" idx="10"/>
+          </p:nvPr>
+        </p:nvSpPr>
+        <p:spPr/>
+        <p:txBody>
+          <a:bodyPr/>
+          <a:lstStyle/>
+          <a:p>
+            <a:fld id="{F7021451-1387-4CA6-816F-3879F97B5CBC}" type="slidenum">
+              <a:rPr lang="en-US"/>
+              <a:t>14</a:t>
+            </a:fld>
+            <a:endParaRPr lang="en-US"/>
+          </a:p>
+        </p:txBody>
+      </p:sp>
+    </p:spTree>
+    <p:extLst>
+      <p:ext uri="{BB962C8B-B14F-4D97-AF65-F5344CB8AC3E}">
+        <p14:creationId xmlns:p14="http://schemas.microsoft.com/office/powerpoint/2010/main" val="1024086991"/>
+      </p:ext>
+    </p:extLst>
+  </p:cSld>
+  <p:clrMapOvr>
+    <a:masterClrMapping/>
+  </p:clrMapOvr>
+</p:notes>
+</file>
+
+<file path=ppt/notesSlides/notesSlide15.xml><?xml version="1.0" encoding="utf-8"?>
+<p:notes xmlns:a="http://schemas.openxmlformats.org/drawingml/2006/main" xmlns:r="http://schemas.openxmlformats.org/officeDocument/2006/relationships" xmlns:p="http://schemas.openxmlformats.org/presentationml/2006/main">
+  <p:cSld>
+    <p:spTree>
+      <p:nvGrpSpPr>
+        <p:cNvPr id="1" name=""/>
+        <p:cNvGrpSpPr/>
+        <p:nvPr/>
+      </p:nvGrpSpPr>
+      <p:grpSpPr>
+        <a:xfrm>
+          <a:off x="0" y="0"/>
+          <a:ext cx="0" cy="0"/>
+          <a:chOff x="0" y="0"/>
+          <a:chExt cx="0" cy="0"/>
+        </a:xfrm>
+      </p:grpSpPr>
+      <p:sp>
+        <p:nvSpPr>
+          <p:cNvPr id="2" name="Slide Image Placeholder 1"/>
+          <p:cNvSpPr>
+            <a:spLocks noGrp="1" noRot="1" noChangeAspect="1"/>
+          </p:cNvSpPr>
+          <p:nvPr>
+            <p:ph type="sldImg"/>
+          </p:nvPr>
+        </p:nvSpPr>
+        <p:spPr/>
+      </p:sp>
+      <p:sp>
+        <p:nvSpPr>
+          <p:cNvPr id="3" name="Notes Placeholder 2"/>
+          <p:cNvSpPr>
+            <a:spLocks noGrp="1"/>
+          </p:cNvSpPr>
+          <p:nvPr>
+            <p:ph type="body" idx="1"/>
+          </p:nvPr>
+        </p:nvSpPr>
+        <p:spPr/>
+        <p:txBody>
+          <a:bodyPr/>
+          <a:lstStyle/>
+          <a:p>
+            <a:r>
+              <a:rPr lang="en-US" dirty="0"/>
+              <a:t>Estas son las fuentes del trabajo.</a:t>
+            </a:r>
+            <a:endParaRPr lang="en-US" dirty="0"/>
+          </a:p>
+        </p:txBody>
+      </p:sp>
+      <p:sp>
+        <p:nvSpPr>
+          <p:cNvPr id="4" name="Slide Number Placeholder 3"/>
+          <p:cNvSpPr>
+            <a:spLocks noGrp="1"/>
+          </p:cNvSpPr>
+          <p:nvPr>
+            <p:ph type="sldNum" sz="quarter" idx="10"/>
+          </p:nvPr>
+        </p:nvSpPr>
+        <p:spPr/>
+        <p:txBody>
+          <a:bodyPr/>
+          <a:lstStyle/>
+          <a:p>
+            <a:fld id="{F7021451-1387-4CA6-816F-3879F97B5CBC}" type="slidenum">
+              <a:rPr lang="en-US"/>
+              <a:t>15</a:t>
+            </a:fld>
+            <a:endParaRPr lang="en-US"/>
+          </a:p>
+        </p:txBody>
+      </p:sp>
+    </p:spTree>
+    <p:extLst>
+      <p:ext uri="{BB962C8B-B14F-4D97-AF65-F5344CB8AC3E}">
+        <p14:creationId xmlns:p14="http://schemas.microsoft.com/office/powerpoint/2010/main" val="1024086991"/>
+      </p:ext>
+    </p:extLst>
+  </p:cSld>
+  <p:clrMapOvr>
+    <a:masterClrMapping/>
+  </p:clrMapOvr>
+</p:notes>
+</file>
+
 <file path=ppt/notesSlides/notesSlide2.xml><?xml version="1.0" encoding="utf-8"?>
+<p:notes xmlns:a="http://schemas.openxmlformats.org/drawingml/2006/main" xmlns:r="http://schemas.openxmlformats.org/officeDocument/2006/relationships" xmlns:p="http://schemas.openxmlformats.org/presentationml/2006/main">
+  <p:cSld>
+    <p:spTree>
+      <p:nvGrpSpPr>
+        <p:cNvPr id="1" name=""/>
+        <p:cNvGrpSpPr/>
+        <p:nvPr/>
+      </p:nvGrpSpPr>
+      <p:grpSpPr>
+        <a:xfrm>
+          <a:off x="0" y="0"/>
+          <a:ext cx="0" cy="0"/>
+          <a:chOff x="0" y="0"/>
+          <a:chExt cx="0" cy="0"/>
+        </a:xfrm>
+      </p:grpSpPr>
+      <p:sp>
+        <p:nvSpPr>
+          <p:cNvPr id="2" name="Slide Image Placeholder 1"/>
+          <p:cNvSpPr>
+            <a:spLocks noGrp="1" noRot="1" noChangeAspect="1"/>
+          </p:cNvSpPr>
+          <p:nvPr>
+            <p:ph type="sldImg"/>
+          </p:nvPr>
+        </p:nvSpPr>
+        <p:spPr/>
+      </p:sp>
+      <p:sp>
+        <p:nvSpPr>
+          <p:cNvPr id="3" name="Notes Placeholder 2"/>
+          <p:cNvSpPr>
+            <a:spLocks noGrp="1"/>
+          </p:cNvSpPr>
+          <p:nvPr>
+            <p:ph type="body" idx="1"/>
+          </p:nvPr>
+        </p:nvSpPr>
+        <p:spPr/>
+        <p:txBody>
+          <a:bodyPr/>
+          <a:lstStyle/>
+          <a:p>
+            <a:r>
+              <a:rPr lang="en-US" dirty="0"/>
+              <a:t>El objetivo fue evaluar el riesgo de incendio del CEDI con el método MESERI, ver qué lo aumenta y qué lo reduce, y proponer mejoras. La información salió de fotos de la inspección, de Google Maps, de datos que dio el personal del CEDI y de las tablas del método vistas en clase.</a:t>
+            </a:r>
+            <a:endParaRPr lang="en-US" dirty="0"/>
+          </a:p>
+        </p:txBody>
+      </p:sp>
+      <p:sp>
+        <p:nvSpPr>
+          <p:cNvPr id="4" name="Slide Number Placeholder 3"/>
+          <p:cNvSpPr>
+            <a:spLocks noGrp="1"/>
+          </p:cNvSpPr>
+          <p:nvPr>
+            <p:ph type="sldNum" sz="quarter" idx="10"/>
+          </p:nvPr>
+        </p:nvSpPr>
+        <p:spPr/>
+        <p:txBody>
+          <a:bodyPr/>
+          <a:lstStyle/>
+          <a:p>
+            <a:fld id="{F7021451-1387-4CA6-816F-3879F97B5CBC}" type="slidenum">
+              <a:rPr lang="en-US"/>
+              <a:t>2</a:t>
+            </a:fld>
+            <a:endParaRPr lang="en-US"/>
+          </a:p>
+        </p:txBody>
+      </p:sp>
+    </p:spTree>
+    <p:extLst>
+      <p:ext uri="{BB962C8B-B14F-4D97-AF65-F5344CB8AC3E}">
+        <p14:creationId xmlns:p14="http://schemas.microsoft.com/office/powerpoint/2010/main" val="1024086991"/>
+      </p:ext>
+    </p:extLst>
+  </p:cSld>
+  <p:clrMapOvr>
+    <a:masterClrMapping/>
+  </p:clrMapOvr>
+</p:notes>
+</file>
+
+<file path=ppt/notesSlides/notesSlide3.xml><?xml version="1.0" encoding="utf-8"?>
 <p:notes xmlns:a="http://schemas.openxmlformats.org/drawingml/2006/main" xmlns:r="http://schemas.openxmlformats.org/officeDocument/2006/relationships" xmlns:p="http://schemas.openxmlformats.org/presentationml/2006/main">
   <p:cSld>
     <p:spTree>
@@ -620,7 +1243,7 @@
           <a:p>
             <a:fld id="{F7021451-1387-4CA6-816F-3879F97B5CBC}" type="slidenum">
               <a:rPr lang="en-US"/>
-              <a:t>2</a:t>
+              <a:t>3</a:t>
             </a:fld>
             <a:endParaRPr lang="en-US"/>
           </a:p>
@@ -639,7 +1262,7 @@
 </p:notes>
 </file>
 
-<file path=ppt/notesSlides/notesSlide3.xml><?xml version="1.0" encoding="utf-8"?>
+<file path=ppt/notesSlides/notesSlide4.xml><?xml version="1.0" encoding="utf-8"?>
 <p:notes xmlns:a="http://schemas.openxmlformats.org/drawingml/2006/main" xmlns:r="http://schemas.openxmlformats.org/officeDocument/2006/relationships" xmlns:p="http://schemas.openxmlformats.org/presentationml/2006/main">
   <p:cSld>
     <p:spTree>
@@ -708,7 +1331,7 @@
           <a:p>
             <a:fld id="{F7021451-1387-4CA6-816F-3879F97B5CBC}" type="slidenum">
               <a:rPr lang="en-US"/>
-              <a:t>3</a:t>
+              <a:t>4</a:t>
             </a:fld>
             <a:endParaRPr lang="en-US"/>
           </a:p>
@@ -727,7 +1350,7 @@
 </p:notes>
 </file>
 
-<file path=ppt/notesSlides/notesSlide4.xml><?xml version="1.0" encoding="utf-8"?>
+<file path=ppt/notesSlides/notesSlide5.xml><?xml version="1.0" encoding="utf-8"?>
 <p:notes xmlns:a="http://schemas.openxmlformats.org/drawingml/2006/main" xmlns:r="http://schemas.openxmlformats.org/officeDocument/2006/relationships" xmlns:p="http://schemas.openxmlformats.org/presentationml/2006/main">
   <p:cSld>
     <p:spTree>
@@ -773,7 +1396,7 @@
           <a:p>
             <a:r>
               <a:rPr lang="en-US" dirty="0"/>
-              <a:t>En los factores propios el CEDI obtuvo 57 de 129 puntos, es decir, el edificio por sí solo es desfavorable. A su favor tiene que la estación de bomberos de Lebrija está a solo 3,4 kilómetros, a 5 minutos, y que el acceso es amplio y pavimentado.</a:t>
+              <a:t>En construcción: la altura es de 18 metros; la tabla dice que entre 15 y 20 metros vale 1, y como se toma el menor entre pisos y altura, queda 1. El edificio es un solo sector de 17.432 metros cuadrados sin muros cortafuego; la tabla dice que si supera 4.500 metros vale 0. La estructura es mixta, concreto y metal, así que se tomó un valor intermedio: 7. Y la bodega no tiene cielo raso, por eso vale 5.</a:t>
             </a:r>
             <a:endParaRPr lang="en-US" dirty="0"/>
           </a:p>
@@ -796,7 +1419,7 @@
           <a:p>
             <a:fld id="{F7021451-1387-4CA6-816F-3879F97B5CBC}" type="slidenum">
               <a:rPr lang="en-US"/>
-              <a:t>4</a:t>
+              <a:t>5</a:t>
             </a:fld>
             <a:endParaRPr lang="en-US"/>
           </a:p>
@@ -815,7 +1438,7 @@
 </p:notes>
 </file>
 
-<file path=ppt/notesSlides/notesSlide5.xml><?xml version="1.0" encoding="utf-8"?>
+<file path=ppt/notesSlides/notesSlide6.xml><?xml version="1.0" encoding="utf-8"?>
 <p:notes xmlns:a="http://schemas.openxmlformats.org/drawingml/2006/main" xmlns:r="http://schemas.openxmlformats.org/officeDocument/2006/relationships" xmlns:p="http://schemas.openxmlformats.org/presentationml/2006/main">
   <p:cSld>
     <p:spTree>
@@ -861,7 +1484,7 @@
           <a:p>
             <a:r>
               <a:rPr lang="en-US" dirty="0"/>
-              <a:t>Las razones principales son cuatro. Primero, es un solo espacio de 17.000 metros cuadrados sin muros cortafuego. Segundo, la mercancía está apilada a unos 10 metros de altura. Tercero, tiene una carga térmica alta, por el cartón, el plástico y los alimentos. Y cuarto, la mercancía vale cerca de 500.000 millones de pesos, así que el calor y el humo la dañarían por completo. Todos estos factores tienen coeficiente 0.</a:t>
+              <a:t>En situación: los bomberos están a 3,4 kilómetros y 5 minutos; la tabla dice que menos de 5 kilómetros vale 10, el máximo. El acceso tiene una portería de 8 metros, más de los 4 que pide la tabla, y vía alrededor del edificio, así que es buena: 5. En concentración de valores, el inventario vale unos 500.000 millones de pesos; dividido entre el área da unos 28,7 millones por metro cuadrado, muy por encima del límite de la tabla, por eso vale 0.</a:t>
             </a:r>
             <a:endParaRPr lang="en-US" dirty="0"/>
           </a:p>
@@ -884,7 +1507,7 @@
           <a:p>
             <a:fld id="{F7021451-1387-4CA6-816F-3879F97B5CBC}" type="slidenum">
               <a:rPr lang="en-US"/>
-              <a:t>5</a:t>
+              <a:t>6</a:t>
             </a:fld>
             <a:endParaRPr lang="en-US"/>
           </a:p>
@@ -903,7 +1526,7 @@
 </p:notes>
 </file>
 
-<file path=ppt/notesSlides/notesSlide6.xml><?xml version="1.0" encoding="utf-8"?>
+<file path=ppt/notesSlides/notesSlide7.xml><?xml version="1.0" encoding="utf-8"?>
 <p:notes xmlns:a="http://schemas.openxmlformats.org/drawingml/2006/main" xmlns:r="http://schemas.openxmlformats.org/officeDocument/2006/relationships" xmlns:p="http://schemas.openxmlformats.org/presentationml/2006/main">
   <p:cSld>
     <p:spTree>
@@ -949,7 +1572,7 @@
           <a:p>
             <a:r>
               <a:rPr lang="en-US" dirty="0"/>
-              <a:t>En protección le va muy bien: 22 de 26 puntos. Tiene rociadores automáticos en todo el edificio, que es lo que más suma, con 8 puntos. Además tiene detección automática, gabinetes contra incendio, un hidrante exterior y extintores señalizados. Todo cuenta con vigilancia permanente y mantenimiento.</a:t>
+              <a:t>En procesos: no hay llama abierta, pero sí carga de montacargas y una cocina con cableado expuesto, por eso el peligro de activación es medio: 5. La carga térmica es alta por la cantidad de cartón, plástico y alimentos, así que vale 0. Los materiales son de combustibilidad media: 3. El orden es medio por la acumulación de estibas: 5. Y el almacenamiento: las estanterías miden unos 10 metros; la tabla dice que si supera 6 metros vale 0, por eso se asignó 0.</a:t>
             </a:r>
             <a:endParaRPr lang="en-US" dirty="0"/>
           </a:p>
@@ -972,7 +1595,7 @@
           <a:p>
             <a:fld id="{F7021451-1387-4CA6-816F-3879F97B5CBC}" type="slidenum">
               <a:rPr lang="en-US"/>
-              <a:t>6</a:t>
+              <a:t>7</a:t>
             </a:fld>
             <a:endParaRPr lang="en-US"/>
           </a:p>
@@ -991,7 +1614,7 @@
 </p:notes>
 </file>
 
-<file path=ppt/notesSlides/notesSlide7.xml><?xml version="1.0" encoding="utf-8"?>
+<file path=ppt/notesSlides/notesSlide8.xml><?xml version="1.0" encoding="utf-8"?>
 <p:notes xmlns:a="http://schemas.openxmlformats.org/drawingml/2006/main" xmlns:r="http://schemas.openxmlformats.org/officeDocument/2006/relationships" xmlns:p="http://schemas.openxmlformats.org/presentationml/2006/main">
   <p:cSld>
     <p:spTree>
@@ -1037,7 +1660,7 @@
           <a:p>
             <a:r>
               <a:rPr lang="en-US" dirty="0"/>
-              <a:t>Al aplicar la fórmula: 5 por 57 sobre 129 da 2,21. 5 por 22 sobre 26 da 4,23. Y la brigada suma 0, porque el CEDI no tiene brigada contra incendios. El resultado es P igual a 6,44, que corresponde a un riesgo bueno. P es el coeficiente de protección contra incendios: va de 0 a 10, y mientras más alto, más seguro está el lugar.</a:t>
+              <a:t>En propagabilidad, el fuego se podría extender entre bloques porque no hay muros cortafuego, y podría subir al mezanine por los ventanales: ambas son medias, 3 cada una. En destructibilidad, el calor y el humo dañarían por completo los alimentos, por eso valen 0. La corrosión y el agua dañan solo parte del inventario: 5 cada una.</a:t>
             </a:r>
             <a:endParaRPr lang="en-US" dirty="0"/>
           </a:p>
@@ -1060,7 +1683,7 @@
           <a:p>
             <a:fld id="{F7021451-1387-4CA6-816F-3879F97B5CBC}" type="slidenum">
               <a:rPr lang="en-US"/>
-              <a:t>7</a:t>
+              <a:t>8</a:t>
             </a:fld>
             <a:endParaRPr lang="en-US"/>
           </a:p>
@@ -1079,7 +1702,7 @@
 </p:notes>
 </file>
 
-<file path=ppt/notesSlides/notesSlide8.xml><?xml version="1.0" encoding="utf-8"?>
+<file path=ppt/notesSlides/notesSlide9.xml><?xml version="1.0" encoding="utf-8"?>
 <p:notes xmlns:a="http://schemas.openxmlformats.org/drawingml/2006/main" xmlns:r="http://schemas.openxmlformats.org/officeDocument/2006/relationships" xmlns:p="http://schemas.openxmlformats.org/presentationml/2006/main">
   <p:cSld>
     <p:spTree>
@@ -1125,7 +1748,7 @@
           <a:p>
             <a:r>
               <a:rPr lang="en-US" dirty="0"/>
-              <a:t>En conclusión, el edificio tiene condiciones de riesgo altas, pero sus sistemas de protección las compensan. Recomiendo tres cosas: conformar una brigada contra incendios, con la que el resultado subiría a 7,44; mantener las pruebas de los rociadores y del hidrante; y corregir el cableado expuesto de la cocina. Muchas gracias. (Si preguntan por qué todo es con vigilancia: porque el CEDI tiene personal de seguridad permanente en portería y los equipos reciben mantenimiento.)</a:t>
+              <a:t>En los factores propios el CEDI obtuvo 57 de 129 puntos, es decir, el edificio por sí solo es desfavorable. A su favor tiene que la estación de bomberos de Lebrija está a solo 3,4 kilómetros, a 5 minutos, y que el acceso es amplio y pavimentado. Seis factores obtuvieron 0, y son los que más aumentan el riesgo.</a:t>
             </a:r>
             <a:endParaRPr lang="en-US" dirty="0"/>
           </a:p>
@@ -1148,7 +1771,7 @@
           <a:p>
             <a:fld id="{F7021451-1387-4CA6-816F-3879F97B5CBC}" type="slidenum">
               <a:rPr lang="en-US"/>
-              <a:t>8</a:t>
+              <a:t>9</a:t>
             </a:fld>
             <a:endParaRPr lang="en-US"/>
           </a:p>
@@ -1493,7 +2116,7 @@
       </p:grpSpPr>
       <p:pic>
         <p:nvPicPr>
-          <p:cNvPr id="2" name="Diapositiva 1" descr="/tmp/claude-0/-home-user-cedi-d1-lebrija/46e3a16f-f43b-510e-9032-e476e8d715c5/scratchpad/ppt/img/s-1.jpg">    </p:cNvPr>
+          <p:cNvPr id="2" name="Diapositiva 1" descr="/tmp/claude-0/-home-user-cedi-d1-lebrija/46e3a16f-f43b-510e-9032-e476e8d715c5/scratchpad/ppt/img/s-01.jpg">    </p:cNvPr>
           <p:cNvPicPr>
             <a:picLocks noChangeAspect="1"/>
           </p:cNvPicPr>
@@ -1523,9 +2146,9 @@
 </p:sld>
 </file>
 
-<file path=ppt/slides/slide2.xml><?xml version="1.0" encoding="utf-8"?>
+<file path=ppt/slides/slide10.xml><?xml version="1.0" encoding="utf-8"?>
 <p:sld xmlns:a="http://schemas.openxmlformats.org/drawingml/2006/main" xmlns:r="http://schemas.openxmlformats.org/officeDocument/2006/relationships" xmlns:p="http://schemas.openxmlformats.org/presentationml/2006/main">
-  <p:cSld name="Slide 2">
+  <p:cSld name="Slide 10">
     <p:spTree>
       <p:nvGrpSpPr>
         <p:cNvPr id="1" name=""/>
@@ -1542,7 +2165,7 @@
       </p:grpSpPr>
       <p:pic>
         <p:nvPicPr>
-          <p:cNvPr id="2" name="Diapositiva 2" descr="/tmp/claude-0/-home-user-cedi-d1-lebrija/46e3a16f-f43b-510e-9032-e476e8d715c5/scratchpad/ppt/img/s-2.jpg">    </p:cNvPr>
+          <p:cNvPr id="2" name="Diapositiva 10" descr="/tmp/claude-0/-home-user-cedi-d1-lebrija/46e3a16f-f43b-510e-9032-e476e8d715c5/scratchpad/ppt/img/s-10.jpg">    </p:cNvPr>
           <p:cNvPicPr>
             <a:picLocks noChangeAspect="1"/>
           </p:cNvPicPr>
@@ -1572,9 +2195,9 @@
 </p:sld>
 </file>
 
-<file path=ppt/slides/slide3.xml><?xml version="1.0" encoding="utf-8"?>
+<file path=ppt/slides/slide11.xml><?xml version="1.0" encoding="utf-8"?>
 <p:sld xmlns:a="http://schemas.openxmlformats.org/drawingml/2006/main" xmlns:r="http://schemas.openxmlformats.org/officeDocument/2006/relationships" xmlns:p="http://schemas.openxmlformats.org/presentationml/2006/main">
-  <p:cSld name="Slide 3">
+  <p:cSld name="Slide 11">
     <p:spTree>
       <p:nvGrpSpPr>
         <p:cNvPr id="1" name=""/>
@@ -1591,7 +2214,7 @@
       </p:grpSpPr>
       <p:pic>
         <p:nvPicPr>
-          <p:cNvPr id="2" name="Diapositiva 3" descr="/tmp/claude-0/-home-user-cedi-d1-lebrija/46e3a16f-f43b-510e-9032-e476e8d715c5/scratchpad/ppt/img/s-3.jpg">    </p:cNvPr>
+          <p:cNvPr id="2" name="Diapositiva 11" descr="/tmp/claude-0/-home-user-cedi-d1-lebrija/46e3a16f-f43b-510e-9032-e476e8d715c5/scratchpad/ppt/img/s-11.jpg">    </p:cNvPr>
           <p:cNvPicPr>
             <a:picLocks noChangeAspect="1"/>
           </p:cNvPicPr>
@@ -1621,9 +2244,9 @@
 </p:sld>
 </file>
 
-<file path=ppt/slides/slide4.xml><?xml version="1.0" encoding="utf-8"?>
+<file path=ppt/slides/slide12.xml><?xml version="1.0" encoding="utf-8"?>
 <p:sld xmlns:a="http://schemas.openxmlformats.org/drawingml/2006/main" xmlns:r="http://schemas.openxmlformats.org/officeDocument/2006/relationships" xmlns:p="http://schemas.openxmlformats.org/presentationml/2006/main">
-  <p:cSld name="Slide 4">
+  <p:cSld name="Slide 12">
     <p:spTree>
       <p:nvGrpSpPr>
         <p:cNvPr id="1" name=""/>
@@ -1640,7 +2263,7 @@
       </p:grpSpPr>
       <p:pic>
         <p:nvPicPr>
-          <p:cNvPr id="2" name="Diapositiva 4" descr="/tmp/claude-0/-home-user-cedi-d1-lebrija/46e3a16f-f43b-510e-9032-e476e8d715c5/scratchpad/ppt/img/s-4.jpg">    </p:cNvPr>
+          <p:cNvPr id="2" name="Diapositiva 12" descr="/tmp/claude-0/-home-user-cedi-d1-lebrija/46e3a16f-f43b-510e-9032-e476e8d715c5/scratchpad/ppt/img/s-12.jpg">    </p:cNvPr>
           <p:cNvPicPr>
             <a:picLocks noChangeAspect="1"/>
           </p:cNvPicPr>
@@ -1670,9 +2293,9 @@
 </p:sld>
 </file>
 
-<file path=ppt/slides/slide5.xml><?xml version="1.0" encoding="utf-8"?>
+<file path=ppt/slides/slide13.xml><?xml version="1.0" encoding="utf-8"?>
 <p:sld xmlns:a="http://schemas.openxmlformats.org/drawingml/2006/main" xmlns:r="http://schemas.openxmlformats.org/officeDocument/2006/relationships" xmlns:p="http://schemas.openxmlformats.org/presentationml/2006/main">
-  <p:cSld name="Slide 5">
+  <p:cSld name="Slide 13">
     <p:spTree>
       <p:nvGrpSpPr>
         <p:cNvPr id="1" name=""/>
@@ -1689,7 +2312,7 @@
       </p:grpSpPr>
       <p:pic>
         <p:nvPicPr>
-          <p:cNvPr id="2" name="Diapositiva 5" descr="/tmp/claude-0/-home-user-cedi-d1-lebrija/46e3a16f-f43b-510e-9032-e476e8d715c5/scratchpad/ppt/img/s-5.jpg">    </p:cNvPr>
+          <p:cNvPr id="2" name="Diapositiva 13" descr="/tmp/claude-0/-home-user-cedi-d1-lebrija/46e3a16f-f43b-510e-9032-e476e8d715c5/scratchpad/ppt/img/s-13.jpg">    </p:cNvPr>
           <p:cNvPicPr>
             <a:picLocks noChangeAspect="1"/>
           </p:cNvPicPr>
@@ -1719,9 +2342,9 @@
 </p:sld>
 </file>
 
-<file path=ppt/slides/slide6.xml><?xml version="1.0" encoding="utf-8"?>
+<file path=ppt/slides/slide14.xml><?xml version="1.0" encoding="utf-8"?>
 <p:sld xmlns:a="http://schemas.openxmlformats.org/drawingml/2006/main" xmlns:r="http://schemas.openxmlformats.org/officeDocument/2006/relationships" xmlns:p="http://schemas.openxmlformats.org/presentationml/2006/main">
-  <p:cSld name="Slide 6">
+  <p:cSld name="Slide 14">
     <p:spTree>
       <p:nvGrpSpPr>
         <p:cNvPr id="1" name=""/>
@@ -1738,7 +2361,7 @@
       </p:grpSpPr>
       <p:pic>
         <p:nvPicPr>
-          <p:cNvPr id="2" name="Diapositiva 6" descr="/tmp/claude-0/-home-user-cedi-d1-lebrija/46e3a16f-f43b-510e-9032-e476e8d715c5/scratchpad/ppt/img/s-6.jpg">    </p:cNvPr>
+          <p:cNvPr id="2" name="Diapositiva 14" descr="/tmp/claude-0/-home-user-cedi-d1-lebrija/46e3a16f-f43b-510e-9032-e476e8d715c5/scratchpad/ppt/img/s-14.jpg">    </p:cNvPr>
           <p:cNvPicPr>
             <a:picLocks noChangeAspect="1"/>
           </p:cNvPicPr>
@@ -1768,9 +2391,9 @@
 </p:sld>
 </file>
 
-<file path=ppt/slides/slide7.xml><?xml version="1.0" encoding="utf-8"?>
+<file path=ppt/slides/slide15.xml><?xml version="1.0" encoding="utf-8"?>
 <p:sld xmlns:a="http://schemas.openxmlformats.org/drawingml/2006/main" xmlns:r="http://schemas.openxmlformats.org/officeDocument/2006/relationships" xmlns:p="http://schemas.openxmlformats.org/presentationml/2006/main">
-  <p:cSld name="Slide 7">
+  <p:cSld name="Slide 15">
     <p:spTree>
       <p:nvGrpSpPr>
         <p:cNvPr id="1" name=""/>
@@ -1787,7 +2410,7 @@
       </p:grpSpPr>
       <p:pic>
         <p:nvPicPr>
-          <p:cNvPr id="2" name="Diapositiva 7" descr="/tmp/claude-0/-home-user-cedi-d1-lebrija/46e3a16f-f43b-510e-9032-e476e8d715c5/scratchpad/ppt/img/s-7.jpg">    </p:cNvPr>
+          <p:cNvPr id="2" name="Diapositiva 15" descr="/tmp/claude-0/-home-user-cedi-d1-lebrija/46e3a16f-f43b-510e-9032-e476e8d715c5/scratchpad/ppt/img/s-15.jpg">    </p:cNvPr>
           <p:cNvPicPr>
             <a:picLocks noChangeAspect="1"/>
           </p:cNvPicPr>
@@ -1817,6 +2440,300 @@
 </p:sld>
 </file>
 
+<file path=ppt/slides/slide2.xml><?xml version="1.0" encoding="utf-8"?>
+<p:sld xmlns:a="http://schemas.openxmlformats.org/drawingml/2006/main" xmlns:r="http://schemas.openxmlformats.org/officeDocument/2006/relationships" xmlns:p="http://schemas.openxmlformats.org/presentationml/2006/main">
+  <p:cSld name="Slide 2">
+    <p:spTree>
+      <p:nvGrpSpPr>
+        <p:cNvPr id="1" name=""/>
+        <p:cNvGrpSpPr/>
+        <p:nvPr/>
+      </p:nvGrpSpPr>
+      <p:grpSpPr>
+        <a:xfrm>
+          <a:off x="0" y="0"/>
+          <a:ext cx="0" cy="0"/>
+          <a:chOff x="0" y="0"/>
+          <a:chExt cx="0" cy="0"/>
+        </a:xfrm>
+      </p:grpSpPr>
+      <p:pic>
+        <p:nvPicPr>
+          <p:cNvPr id="2" name="Diapositiva 2" descr="/tmp/claude-0/-home-user-cedi-d1-lebrija/46e3a16f-f43b-510e-9032-e476e8d715c5/scratchpad/ppt/img/s-02.jpg">    </p:cNvPr>
+          <p:cNvPicPr>
+            <a:picLocks noChangeAspect="1"/>
+          </p:cNvPicPr>
+          <p:nvPr/>
+        </p:nvPicPr>
+        <p:blipFill>
+          <a:blip r:embed="rId1"/>
+          <a:stretch>
+            <a:fillRect/>
+          </a:stretch>
+        </p:blipFill>
+        <p:spPr>
+          <a:xfrm>
+            <a:off x="0" y="0"/>
+            <a:ext cx="12191695" cy="6858000"/>
+          </a:xfrm>
+          <a:prstGeom prst="rect">
+            <a:avLst/>
+          </a:prstGeom>
+        </p:spPr>
+      </p:pic>
+    </p:spTree>
+  </p:cSld>
+  <p:clrMapOvr>
+    <a:masterClrMapping/>
+  </p:clrMapOvr>
+</p:sld>
+</file>
+
+<file path=ppt/slides/slide3.xml><?xml version="1.0" encoding="utf-8"?>
+<p:sld xmlns:a="http://schemas.openxmlformats.org/drawingml/2006/main" xmlns:r="http://schemas.openxmlformats.org/officeDocument/2006/relationships" xmlns:p="http://schemas.openxmlformats.org/presentationml/2006/main">
+  <p:cSld name="Slide 3">
+    <p:spTree>
+      <p:nvGrpSpPr>
+        <p:cNvPr id="1" name=""/>
+        <p:cNvGrpSpPr/>
+        <p:nvPr/>
+      </p:nvGrpSpPr>
+      <p:grpSpPr>
+        <a:xfrm>
+          <a:off x="0" y="0"/>
+          <a:ext cx="0" cy="0"/>
+          <a:chOff x="0" y="0"/>
+          <a:chExt cx="0" cy="0"/>
+        </a:xfrm>
+      </p:grpSpPr>
+      <p:pic>
+        <p:nvPicPr>
+          <p:cNvPr id="2" name="Diapositiva 3" descr="/tmp/claude-0/-home-user-cedi-d1-lebrija/46e3a16f-f43b-510e-9032-e476e8d715c5/scratchpad/ppt/img/s-03.jpg">    </p:cNvPr>
+          <p:cNvPicPr>
+            <a:picLocks noChangeAspect="1"/>
+          </p:cNvPicPr>
+          <p:nvPr/>
+        </p:nvPicPr>
+        <p:blipFill>
+          <a:blip r:embed="rId1"/>
+          <a:stretch>
+            <a:fillRect/>
+          </a:stretch>
+        </p:blipFill>
+        <p:spPr>
+          <a:xfrm>
+            <a:off x="0" y="0"/>
+            <a:ext cx="12191695" cy="6858000"/>
+          </a:xfrm>
+          <a:prstGeom prst="rect">
+            <a:avLst/>
+          </a:prstGeom>
+        </p:spPr>
+      </p:pic>
+    </p:spTree>
+  </p:cSld>
+  <p:clrMapOvr>
+    <a:masterClrMapping/>
+  </p:clrMapOvr>
+</p:sld>
+</file>
+
+<file path=ppt/slides/slide4.xml><?xml version="1.0" encoding="utf-8"?>
+<p:sld xmlns:a="http://schemas.openxmlformats.org/drawingml/2006/main" xmlns:r="http://schemas.openxmlformats.org/officeDocument/2006/relationships" xmlns:p="http://schemas.openxmlformats.org/presentationml/2006/main">
+  <p:cSld name="Slide 4">
+    <p:spTree>
+      <p:nvGrpSpPr>
+        <p:cNvPr id="1" name=""/>
+        <p:cNvGrpSpPr/>
+        <p:nvPr/>
+      </p:nvGrpSpPr>
+      <p:grpSpPr>
+        <a:xfrm>
+          <a:off x="0" y="0"/>
+          <a:ext cx="0" cy="0"/>
+          <a:chOff x="0" y="0"/>
+          <a:chExt cx="0" cy="0"/>
+        </a:xfrm>
+      </p:grpSpPr>
+      <p:pic>
+        <p:nvPicPr>
+          <p:cNvPr id="2" name="Diapositiva 4" descr="/tmp/claude-0/-home-user-cedi-d1-lebrija/46e3a16f-f43b-510e-9032-e476e8d715c5/scratchpad/ppt/img/s-04.jpg">    </p:cNvPr>
+          <p:cNvPicPr>
+            <a:picLocks noChangeAspect="1"/>
+          </p:cNvPicPr>
+          <p:nvPr/>
+        </p:nvPicPr>
+        <p:blipFill>
+          <a:blip r:embed="rId1"/>
+          <a:stretch>
+            <a:fillRect/>
+          </a:stretch>
+        </p:blipFill>
+        <p:spPr>
+          <a:xfrm>
+            <a:off x="0" y="0"/>
+            <a:ext cx="12191695" cy="6858000"/>
+          </a:xfrm>
+          <a:prstGeom prst="rect">
+            <a:avLst/>
+          </a:prstGeom>
+        </p:spPr>
+      </p:pic>
+    </p:spTree>
+  </p:cSld>
+  <p:clrMapOvr>
+    <a:masterClrMapping/>
+  </p:clrMapOvr>
+</p:sld>
+</file>
+
+<file path=ppt/slides/slide5.xml><?xml version="1.0" encoding="utf-8"?>
+<p:sld xmlns:a="http://schemas.openxmlformats.org/drawingml/2006/main" xmlns:r="http://schemas.openxmlformats.org/officeDocument/2006/relationships" xmlns:p="http://schemas.openxmlformats.org/presentationml/2006/main">
+  <p:cSld name="Slide 5">
+    <p:spTree>
+      <p:nvGrpSpPr>
+        <p:cNvPr id="1" name=""/>
+        <p:cNvGrpSpPr/>
+        <p:nvPr/>
+      </p:nvGrpSpPr>
+      <p:grpSpPr>
+        <a:xfrm>
+          <a:off x="0" y="0"/>
+          <a:ext cx="0" cy="0"/>
+          <a:chOff x="0" y="0"/>
+          <a:chExt cx="0" cy="0"/>
+        </a:xfrm>
+      </p:grpSpPr>
+      <p:pic>
+        <p:nvPicPr>
+          <p:cNvPr id="2" name="Diapositiva 5" descr="/tmp/claude-0/-home-user-cedi-d1-lebrija/46e3a16f-f43b-510e-9032-e476e8d715c5/scratchpad/ppt/img/s-05.jpg">    </p:cNvPr>
+          <p:cNvPicPr>
+            <a:picLocks noChangeAspect="1"/>
+          </p:cNvPicPr>
+          <p:nvPr/>
+        </p:nvPicPr>
+        <p:blipFill>
+          <a:blip r:embed="rId1"/>
+          <a:stretch>
+            <a:fillRect/>
+          </a:stretch>
+        </p:blipFill>
+        <p:spPr>
+          <a:xfrm>
+            <a:off x="0" y="0"/>
+            <a:ext cx="12191695" cy="6858000"/>
+          </a:xfrm>
+          <a:prstGeom prst="rect">
+            <a:avLst/>
+          </a:prstGeom>
+        </p:spPr>
+      </p:pic>
+    </p:spTree>
+  </p:cSld>
+  <p:clrMapOvr>
+    <a:masterClrMapping/>
+  </p:clrMapOvr>
+</p:sld>
+</file>
+
+<file path=ppt/slides/slide6.xml><?xml version="1.0" encoding="utf-8"?>
+<p:sld xmlns:a="http://schemas.openxmlformats.org/drawingml/2006/main" xmlns:r="http://schemas.openxmlformats.org/officeDocument/2006/relationships" xmlns:p="http://schemas.openxmlformats.org/presentationml/2006/main">
+  <p:cSld name="Slide 6">
+    <p:spTree>
+      <p:nvGrpSpPr>
+        <p:cNvPr id="1" name=""/>
+        <p:cNvGrpSpPr/>
+        <p:nvPr/>
+      </p:nvGrpSpPr>
+      <p:grpSpPr>
+        <a:xfrm>
+          <a:off x="0" y="0"/>
+          <a:ext cx="0" cy="0"/>
+          <a:chOff x="0" y="0"/>
+          <a:chExt cx="0" cy="0"/>
+        </a:xfrm>
+      </p:grpSpPr>
+      <p:pic>
+        <p:nvPicPr>
+          <p:cNvPr id="2" name="Diapositiva 6" descr="/tmp/claude-0/-home-user-cedi-d1-lebrija/46e3a16f-f43b-510e-9032-e476e8d715c5/scratchpad/ppt/img/s-06.jpg">    </p:cNvPr>
+          <p:cNvPicPr>
+            <a:picLocks noChangeAspect="1"/>
+          </p:cNvPicPr>
+          <p:nvPr/>
+        </p:nvPicPr>
+        <p:blipFill>
+          <a:blip r:embed="rId1"/>
+          <a:stretch>
+            <a:fillRect/>
+          </a:stretch>
+        </p:blipFill>
+        <p:spPr>
+          <a:xfrm>
+            <a:off x="0" y="0"/>
+            <a:ext cx="12191695" cy="6858000"/>
+          </a:xfrm>
+          <a:prstGeom prst="rect">
+            <a:avLst/>
+          </a:prstGeom>
+        </p:spPr>
+      </p:pic>
+    </p:spTree>
+  </p:cSld>
+  <p:clrMapOvr>
+    <a:masterClrMapping/>
+  </p:clrMapOvr>
+</p:sld>
+</file>
+
+<file path=ppt/slides/slide7.xml><?xml version="1.0" encoding="utf-8"?>
+<p:sld xmlns:a="http://schemas.openxmlformats.org/drawingml/2006/main" xmlns:r="http://schemas.openxmlformats.org/officeDocument/2006/relationships" xmlns:p="http://schemas.openxmlformats.org/presentationml/2006/main">
+  <p:cSld name="Slide 7">
+    <p:spTree>
+      <p:nvGrpSpPr>
+        <p:cNvPr id="1" name=""/>
+        <p:cNvGrpSpPr/>
+        <p:nvPr/>
+      </p:nvGrpSpPr>
+      <p:grpSpPr>
+        <a:xfrm>
+          <a:off x="0" y="0"/>
+          <a:ext cx="0" cy="0"/>
+          <a:chOff x="0" y="0"/>
+          <a:chExt cx="0" cy="0"/>
+        </a:xfrm>
+      </p:grpSpPr>
+      <p:pic>
+        <p:nvPicPr>
+          <p:cNvPr id="2" name="Diapositiva 7" descr="/tmp/claude-0/-home-user-cedi-d1-lebrija/46e3a16f-f43b-510e-9032-e476e8d715c5/scratchpad/ppt/img/s-07.jpg">    </p:cNvPr>
+          <p:cNvPicPr>
+            <a:picLocks noChangeAspect="1"/>
+          </p:cNvPicPr>
+          <p:nvPr/>
+        </p:nvPicPr>
+        <p:blipFill>
+          <a:blip r:embed="rId1"/>
+          <a:stretch>
+            <a:fillRect/>
+          </a:stretch>
+        </p:blipFill>
+        <p:spPr>
+          <a:xfrm>
+            <a:off x="0" y="0"/>
+            <a:ext cx="12191695" cy="6858000"/>
+          </a:xfrm>
+          <a:prstGeom prst="rect">
+            <a:avLst/>
+          </a:prstGeom>
+        </p:spPr>
+      </p:pic>
+    </p:spTree>
+  </p:cSld>
+  <p:clrMapOvr>
+    <a:masterClrMapping/>
+  </p:clrMapOvr>
+</p:sld>
+</file>
+
 <file path=ppt/slides/slide8.xml><?xml version="1.0" encoding="utf-8"?>
 <p:sld xmlns:a="http://schemas.openxmlformats.org/drawingml/2006/main" xmlns:r="http://schemas.openxmlformats.org/officeDocument/2006/relationships" xmlns:p="http://schemas.openxmlformats.org/presentationml/2006/main">
   <p:cSld name="Slide 8">
@@ -1836,7 +2753,56 @@
       </p:grpSpPr>
       <p:pic>
         <p:nvPicPr>
-          <p:cNvPr id="2" name="Diapositiva 8" descr="/tmp/claude-0/-home-user-cedi-d1-lebrija/46e3a16f-f43b-510e-9032-e476e8d715c5/scratchpad/ppt/img/s-8.jpg">    </p:cNvPr>
+          <p:cNvPr id="2" name="Diapositiva 8" descr="/tmp/claude-0/-home-user-cedi-d1-lebrija/46e3a16f-f43b-510e-9032-e476e8d715c5/scratchpad/ppt/img/s-08.jpg">    </p:cNvPr>
+          <p:cNvPicPr>
+            <a:picLocks noChangeAspect="1"/>
+          </p:cNvPicPr>
+          <p:nvPr/>
+        </p:nvPicPr>
+        <p:blipFill>
+          <a:blip r:embed="rId1"/>
+          <a:stretch>
+            <a:fillRect/>
+          </a:stretch>
+        </p:blipFill>
+        <p:spPr>
+          <a:xfrm>
+            <a:off x="0" y="0"/>
+            <a:ext cx="12191695" cy="6858000"/>
+          </a:xfrm>
+          <a:prstGeom prst="rect">
+            <a:avLst/>
+          </a:prstGeom>
+        </p:spPr>
+      </p:pic>
+    </p:spTree>
+  </p:cSld>
+  <p:clrMapOvr>
+    <a:masterClrMapping/>
+  </p:clrMapOvr>
+</p:sld>
+</file>
+
+<file path=ppt/slides/slide9.xml><?xml version="1.0" encoding="utf-8"?>
+<p:sld xmlns:a="http://schemas.openxmlformats.org/drawingml/2006/main" xmlns:r="http://schemas.openxmlformats.org/officeDocument/2006/relationships" xmlns:p="http://schemas.openxmlformats.org/presentationml/2006/main">
+  <p:cSld name="Slide 9">
+    <p:spTree>
+      <p:nvGrpSpPr>
+        <p:cNvPr id="1" name=""/>
+        <p:cNvGrpSpPr/>
+        <p:nvPr/>
+      </p:nvGrpSpPr>
+      <p:grpSpPr>
+        <a:xfrm>
+          <a:off x="0" y="0"/>
+          <a:ext cx="0" cy="0"/>
+          <a:chOff x="0" y="0"/>
+          <a:chExt cx="0" cy="0"/>
+        </a:xfrm>
+      </p:grpSpPr>
+      <p:pic>
+        <p:nvPicPr>
+          <p:cNvPr id="2" name="Diapositiva 9" descr="/tmp/claude-0/-home-user-cedi-d1-lebrija/46e3a16f-f43b-510e-9032-e476e8d715c5/scratchpad/ppt/img/s-09.jpg">    </p:cNvPr>
           <p:cNvPicPr>
             <a:picLocks noChangeAspect="1"/>
           </p:cNvPicPr>

</xml_diff>